<commit_message>
Improve research paper and presentation quality
- Add author name (Edward Griggs), CNU, and COVACCI affiliation
- Add APA 7th page numbers, fix Heading 3 italic, fix figure captions
- Add comparison tables for detection techniques and prevention strategies
- Strengthen in-text citations across Risks, Detection, and Discussion
- Rewrite Discussion with flowing analysis instead of formulaic structure
- Enhance Conclusion with specific future direction citations
- Add slide numbers, stat callout (#1 OWASP), severity color coding
- Split detection into two slides, add Questions slide (15 total)
- Shorten slide bullets with accent-colored labels for readability
- Add figure annotations and tradeoff callouts on detection slides
</commit_message>
<xml_diff>
--- a/output/presentation.pptx
+++ b/output/presentation.pptx
@@ -18,6 +18,8 @@
     <p:sldId id="266" r:id="rId18"/>
     <p:sldId id="267" r:id="rId19"/>
     <p:sldId id="268" r:id="rId20"/>
+    <p:sldId id="269" r:id="rId21"/>
+    <p:sldId id="270" r:id="rId22"/>
   </p:sldIdLst>
   <p:sldSz cx="12191695" cy="6858000" type="screen4x3"/>
   <p:notesSz cx="6858000" cy="9144000"/>
@@ -584,7 +586,7 @@
           <a:lstStyle/>
           <a:p>
             <a:r>
-              <a:t>[~45s] Cover the layered defense approach. Emphasize that no single prevention strategy is complete — instruction hierarchy + input sanitization + output filtering together.</a:t>
+              <a:t>[~30s] Walk through the defense pipeline diagram. Each layer catches different attack types. Input sanitization stops known patterns. Detection flags anomalies. Output filtering catches successful attacks. Monitoring provides feedback loop.</a:t>
             </a:r>
           </a:p>
         </p:txBody>
@@ -654,7 +656,7 @@
           <a:lstStyle/>
           <a:p>
             <a:r>
-              <a:t>[~30s] Show the architecture diagram. Highlight how multiple defense layers interact to provide defense in depth.</a:t>
+              <a:t>[~45s] Cover the layered defense approach. Instruction hierarchy is the most promising model-level defense but only model providers can implement it. App developers must layer sanitization + guardrails + output validation. System architects enforce sandboxing and least privilege. Emphasize that no single strategy is complete.</a:t>
             </a:r>
           </a:p>
         </p:txBody>
@@ -724,7 +726,147 @@
           <a:lstStyle/>
           <a:p>
             <a:r>
-              <a:t>[~30s] Highlight 2-3 foundational references. Close with the key takeaway: no silver bullet, defense in depth required. Thank audience, invite questions.</a:t>
+              <a:t>[~30s] Show the architecture diagram. Model providers handle instruction hierarchy. App developers deploy guardrails and filtering. System architects enforce sandboxing and least privilege. All three levels must coordinate for effective defense.</a:t>
+            </a:r>
+          </a:p>
+        </p:txBody>
+      </p:sp>
+      <p:sp>
+        <p:nvSpPr>
+          <p:cNvPr id="4" name="Slide Number Placeholder 3"/>
+          <p:cNvSpPr>
+            <a:spLocks noGrp="1"/>
+          </p:cNvSpPr>
+          <p:nvPr>
+            <p:ph type="sldNum" idx="5" sz="quarter"/>
+          </p:nvPr>
+        </p:nvSpPr>
+        <p:spPr/>
+      </p:sp>
+    </p:spTree>
+  </p:cSld>
+  <p:clrMapOvr>
+    <a:masterClrMapping/>
+  </p:clrMapOvr>
+</p:notes>
+</file>
+
+<file path=ppt/notesSlides/notesSlide13.xml><?xml version="1.0" encoding="utf-8"?>
+<p:notes xmlns:a="http://schemas.openxmlformats.org/drawingml/2006/main" xmlns:p="http://schemas.openxmlformats.org/presentationml/2006/main" xmlns:r="http://schemas.openxmlformats.org/officeDocument/2006/relationships">
+  <p:cSld>
+    <p:spTree>
+      <p:nvGrpSpPr>
+        <p:cNvPr id="1" name=""/>
+        <p:cNvGrpSpPr/>
+        <p:nvPr/>
+      </p:nvGrpSpPr>
+      <p:grpSpPr>
+        <a:xfrm>
+          <a:off x="0" y="0"/>
+          <a:ext cx="0" cy="0"/>
+          <a:chOff x="0" y="0"/>
+          <a:chExt cx="0" cy="0"/>
+        </a:xfrm>
+      </p:grpSpPr>
+      <p:sp>
+        <p:nvSpPr>
+          <p:cNvPr id="2" name="Slide Image Placeholder 1"/>
+          <p:cNvSpPr>
+            <a:spLocks noGrp="1"/>
+          </p:cNvSpPr>
+          <p:nvPr>
+            <p:ph type="sldImg" idx="2"/>
+          </p:nvPr>
+        </p:nvSpPr>
+        <p:spPr/>
+      </p:sp>
+      <p:sp>
+        <p:nvSpPr>
+          <p:cNvPr id="3" name="Notes Placeholder 2"/>
+          <p:cNvSpPr>
+            <a:spLocks noGrp="1"/>
+          </p:cNvSpPr>
+          <p:nvPr>
+            <p:ph type="body" idx="3" sz="quarter"/>
+          </p:nvPr>
+        </p:nvSpPr>
+        <p:spPr/>
+        <p:txBody>
+          <a:bodyPr/>
+          <a:lstStyle/>
+          <a:p>
+            <a:r>
+              <a:t>[~30s] Highlight the three foundational references. Abdallah et al. for comprehensive taxonomy. Greshake et al. for indirect injection formalization. Wallace et al. for instruction hierarchy defense. Close with the key takeaway: no silver bullet, defense in depth required.</a:t>
+            </a:r>
+          </a:p>
+        </p:txBody>
+      </p:sp>
+      <p:sp>
+        <p:nvSpPr>
+          <p:cNvPr id="4" name="Slide Number Placeholder 3"/>
+          <p:cNvSpPr>
+            <a:spLocks noGrp="1"/>
+          </p:cNvSpPr>
+          <p:nvPr>
+            <p:ph type="sldNum" idx="5" sz="quarter"/>
+          </p:nvPr>
+        </p:nvSpPr>
+        <p:spPr/>
+      </p:sp>
+    </p:spTree>
+  </p:cSld>
+  <p:clrMapOvr>
+    <a:masterClrMapping/>
+  </p:clrMapOvr>
+</p:notes>
+</file>
+
+<file path=ppt/notesSlides/notesSlide14.xml><?xml version="1.0" encoding="utf-8"?>
+<p:notes xmlns:a="http://schemas.openxmlformats.org/drawingml/2006/main" xmlns:p="http://schemas.openxmlformats.org/presentationml/2006/main" xmlns:r="http://schemas.openxmlformats.org/officeDocument/2006/relationships">
+  <p:cSld>
+    <p:spTree>
+      <p:nvGrpSpPr>
+        <p:cNvPr id="1" name=""/>
+        <p:cNvGrpSpPr/>
+        <p:nvPr/>
+      </p:nvGrpSpPr>
+      <p:grpSpPr>
+        <a:xfrm>
+          <a:off x="0" y="0"/>
+          <a:ext cx="0" cy="0"/>
+          <a:chOff x="0" y="0"/>
+          <a:chExt cx="0" cy="0"/>
+        </a:xfrm>
+      </p:grpSpPr>
+      <p:sp>
+        <p:nvSpPr>
+          <p:cNvPr id="2" name="Slide Image Placeholder 1"/>
+          <p:cNvSpPr>
+            <a:spLocks noGrp="1"/>
+          </p:cNvSpPr>
+          <p:nvPr>
+            <p:ph type="sldImg" idx="2"/>
+          </p:nvPr>
+        </p:nvSpPr>
+        <p:spPr/>
+      </p:sp>
+      <p:sp>
+        <p:nvSpPr>
+          <p:cNvPr id="3" name="Notes Placeholder 2"/>
+          <p:cNvSpPr>
+            <a:spLocks noGrp="1"/>
+          </p:cNvSpPr>
+          <p:nvPr>
+            <p:ph type="body" idx="3" sz="quarter"/>
+          </p:nvPr>
+        </p:nvSpPr>
+        <p:spPr/>
+        <p:txBody>
+          <a:bodyPr/>
+          <a:lstStyle/>
+          <a:p>
+            <a:r>
+              <a:t>[End] Thank audience. Invite questions. If no questions, reiterate the defense-in-depth message and that prompt injection remains an active research area.</a:t>
             </a:r>
           </a:p>
         </p:txBody>
@@ -794,7 +936,7 @@
           <a:lstStyle/>
           <a:p>
             <a:r>
-              <a:t>[~45s] Define prompt injection clearly. Emphasize the SQL injection analogy — audience likely familiar with web security. Mention OWASP ranking to establish severity.</a:t>
+              <a:t>[~45s] Define prompt injection clearly. Emphasize the SQL injection analogy — audience likely familiar with web security. Point to the #1 OWASP ranking to establish severity.</a:t>
             </a:r>
           </a:p>
         </p:txBody>
@@ -864,7 +1006,7 @@
           <a:lstStyle/>
           <a:p>
             <a:r>
-              <a:t>[~45s] Cover Direct Injection injection. Highlight key subcategories and give one concrete example for each.</a:t>
+              <a:t>[~45s] Cover Direct Injection. Jailbreaking: DAN persona bypasses content policies. Goal hijacking: 'ignore previous instructions' redirects the model's task. Prompt leaking: extracting system prompts reveals application guardrails.</a:t>
             </a:r>
           </a:p>
         </p:txBody>
@@ -934,7 +1076,7 @@
           <a:lstStyle/>
           <a:p>
             <a:r>
-              <a:t>[~45s] Cover Indirect Injection injection. Highlight key subcategories and give one concrete example for each.</a:t>
+              <a:t>[~45s] Cover Indirect Injection. Key insight: attacker plants payload in external content the model will retrieve. RAG poisoning is especially dangerous for enterprise knowledge bases. Email injection can trigger actions like forwarding data to attacker.</a:t>
             </a:r>
           </a:p>
         </p:txBody>
@@ -1004,7 +1146,7 @@
           <a:lstStyle/>
           <a:p>
             <a:r>
-              <a:t>[~30s] Walk through the taxonomy diagram. Point out the hierarchy from category to specific technique.</a:t>
+              <a:t>[~30s] Walk through the taxonomy diagram. Point out the hierarchy from category to specific technique. Note how complexity increases left to right, reflecting the evolution of LLM capabilities.</a:t>
             </a:r>
           </a:p>
         </p:txBody>
@@ -1074,7 +1216,7 @@
           <a:lstStyle/>
           <a:p>
             <a:r>
-              <a:t>[~45s] Emphasize data exfiltration and unauthorized actions as highest-severity outcomes. Give the markdown image exfiltration example — it's vivid and memorable.</a:t>
+              <a:t>[~45s] Emphasize data exfiltration and unauthorized actions as highest-severity outcomes. Give the markdown image exfiltration example — it's vivid and memorable: a poisoned doc encodes data into a URL rendered as an image tag.</a:t>
             </a:r>
           </a:p>
         </p:txBody>
@@ -1144,7 +1286,7 @@
           <a:lstStyle/>
           <a:p>
             <a:r>
-              <a:t>[~30s] Cover remaining risk categories briefly. Highlight that impact scales with agent permission scope.</a:t>
+              <a:t>[~30s] Cover remaining risk categories briefly. Content manipulation is insidious because users trust AI output. Supply chain propagation means one compromised system can cascade to others. Highlight that impact scales with agent permission scope.</a:t>
             </a:r>
           </a:p>
         </p:txBody>
@@ -1214,7 +1356,7 @@
           <a:lstStyle/>
           <a:p>
             <a:r>
-              <a:t>[~45s] Compare static vs learned approaches. Note that no single detection method is sufficient — defense in depth is required.</a:t>
+              <a:t>[~30s] Cover the three pattern-based detection approaches. Heuristic: fast but trivially bypassed via paraphrasing. ML: better coverage but training-data dependent. Perplexity: good for machine-generated adversarial suffixes but not human-crafted prompts.</a:t>
             </a:r>
           </a:p>
         </p:txBody>
@@ -1284,7 +1426,7 @@
           <a:lstStyle/>
           <a:p>
             <a:r>
-              <a:t>[~30s] Walk through the defense pipeline diagram — input sanitization, detection, response filtering, monitoring.</a:t>
+              <a:t>[~30s] Canary tokens: proactive but only catch context leakage. LLM-as-judge: most capable detector but doubles inference cost and the judge itself can be fooled. Key message: no single method works, you need to layer multiple approaches.</a:t>
             </a:r>
           </a:p>
         </p:txBody>
@@ -4306,7 +4448,7 @@
         </p:nvSpPr>
         <p:spPr>
           <a:xfrm>
-            <a:off x="914400" y="1828800"/>
+            <a:off x="914400" y="1645920"/>
             <a:ext cx="10058400" cy="1828800"/>
           </a:xfrm>
           <a:prstGeom prst="rect">
@@ -4341,7 +4483,7 @@
         </p:nvSpPr>
         <p:spPr>
           <a:xfrm>
-            <a:off x="914400" y="3840480"/>
+            <a:off x="914400" y="3474720"/>
             <a:ext cx="10058400" cy="914400"/>
           </a:xfrm>
           <a:prstGeom prst="rect">
@@ -4376,7 +4518,7 @@
         </p:nvSpPr>
         <p:spPr>
           <a:xfrm>
-            <a:off x="914400" y="5029200"/>
+            <a:off x="914400" y="4754880"/>
             <a:ext cx="10058400" cy="548640"/>
           </a:xfrm>
           <a:prstGeom prst="rect">
@@ -4391,14 +4533,84 @@
           <a:lstStyle/>
           <a:p>
             <a:pPr algn="ctr">
-              <a:defRPr sz="1800" b="0">
-                <a:solidFill>
-                  <a:srgbClr val="B4B4B4"/>
+              <a:defRPr sz="2000" b="0">
+                <a:solidFill>
+                  <a:srgbClr val="E6E6E6"/>
                 </a:solidFill>
               </a:defRPr>
             </a:pPr>
             <a:r>
-              <a:t>Cybersecurity Research Division</a:t>
+              <a:t>Edward Griggs</a:t>
+            </a:r>
+          </a:p>
+        </p:txBody>
+      </p:sp>
+      <p:sp>
+        <p:nvSpPr>
+          <p:cNvPr id="5" name="TextBox 4"/>
+          <p:cNvSpPr txBox="1"/>
+          <p:nvPr/>
+        </p:nvSpPr>
+        <p:spPr>
+          <a:xfrm>
+            <a:off x="914400" y="5394960"/>
+            <a:ext cx="10058400" cy="548640"/>
+          </a:xfrm>
+          <a:prstGeom prst="rect">
+            <a:avLst/>
+          </a:prstGeom>
+          <a:noFill/>
+        </p:spPr>
+        <p:txBody>
+          <a:bodyPr wrap="square">
+            <a:spAutoFit/>
+          </a:bodyPr>
+          <a:lstStyle/>
+          <a:p>
+            <a:pPr algn="ctr">
+              <a:defRPr sz="1600" b="0">
+                <a:solidFill>
+                  <a:srgbClr val="B4B4B4"/>
+                </a:solidFill>
+              </a:defRPr>
+            </a:pPr>
+            <a:r>
+              <a:t>Christopher Newport University • COVACCI Cybersecurity Undergraduate Research</a:t>
+            </a:r>
+          </a:p>
+        </p:txBody>
+      </p:sp>
+      <p:sp>
+        <p:nvSpPr>
+          <p:cNvPr id="6" name="TextBox 5"/>
+          <p:cNvSpPr txBox="1"/>
+          <p:nvPr/>
+        </p:nvSpPr>
+        <p:spPr>
+          <a:xfrm>
+            <a:off x="11247120" y="6400800"/>
+            <a:ext cx="731520" cy="365760"/>
+          </a:xfrm>
+          <a:prstGeom prst="rect">
+            <a:avLst/>
+          </a:prstGeom>
+          <a:noFill/>
+        </p:spPr>
+        <p:txBody>
+          <a:bodyPr wrap="square">
+            <a:spAutoFit/>
+          </a:bodyPr>
+          <a:lstStyle/>
+          <a:p>
+            <a:pPr algn="r">
+              <a:defRPr sz="1000" b="0">
+                <a:solidFill>
+                  <a:srgbClr val="8C8C8C"/>
+                </a:solidFill>
+              </a:defRPr>
+            </a:pPr>
+            <a:r>
+              <a:t>1</a:t>
             </a:r>
           </a:p>
         </p:txBody>
@@ -4459,35 +4671,187 @@
               </a:defRPr>
             </a:pPr>
             <a:r>
-              <a:t>Detection &amp; Defense Pipeline</a:t>
-            </a:r>
-          </a:p>
-        </p:txBody>
-      </p:sp>
-      <p:pic>
-        <p:nvPicPr>
-          <p:cNvPr id="3" name="Picture 2" descr="defense_flow.png"/>
-          <p:cNvPicPr>
-            <a:picLocks noChangeAspect="1"/>
-          </p:cNvPicPr>
+              <a:t>Detection Techniques: Active Defense</a:t>
+            </a:r>
+          </a:p>
+        </p:txBody>
+      </p:sp>
+      <p:sp>
+        <p:nvSpPr>
+          <p:cNvPr id="3" name="TextBox 2"/>
+          <p:cNvSpPr txBox="1"/>
           <p:nvPr/>
-        </p:nvPicPr>
-        <p:blipFill>
-          <a:blip r:embed="rId2"/>
-          <a:stretch>
-            <a:fillRect/>
-          </a:stretch>
-        </p:blipFill>
-        <p:spPr>
-          <a:xfrm>
-            <a:off x="1828800" y="1371600"/>
-            <a:ext cx="8229600" cy="4754880"/>
+        </p:nvSpPr>
+        <p:spPr>
+          <a:xfrm>
+            <a:off x="731520" y="1371600"/>
+            <a:ext cx="10515600" cy="4572000"/>
           </a:xfrm>
           <a:prstGeom prst="rect">
             <a:avLst/>
           </a:prstGeom>
-        </p:spPr>
-      </p:pic>
+          <a:noFill/>
+        </p:spPr>
+        <p:txBody>
+          <a:bodyPr wrap="square">
+            <a:spAutoFit/>
+          </a:bodyPr>
+          <a:lstStyle/>
+          <a:p>
+            <a:pPr>
+              <a:spcAft>
+                <a:spcPts val="800"/>
+              </a:spcAft>
+            </a:pPr>
+            <a:r>
+              <a:rPr sz="1700">
+                <a:solidFill>
+                  <a:srgbClr val="E6E6E6"/>
+                </a:solidFill>
+              </a:rPr>
+              <a:t>• </a:t>
+            </a:r>
+            <a:r>
+              <a:rPr sz="1700" b="1">
+                <a:solidFill>
+                  <a:srgbClr val="FFAA3C"/>
+                </a:solidFill>
+              </a:rPr>
+              <a:t>Canary Tokens</a:t>
+            </a:r>
+            <a:r>
+              <a:rPr sz="1700">
+                <a:solidFill>
+                  <a:srgbClr val="E6E6E6"/>
+                </a:solidFill>
+              </a:rPr>
+              <a:t> — secret strings planted in system prompt — if they appear in output, injection succeeded</a:t>
+            </a:r>
+          </a:p>
+          <a:p>
+            <a:pPr>
+              <a:spcAft>
+                <a:spcPts val="800"/>
+              </a:spcAft>
+            </a:pPr>
+            <a:r>
+              <a:rPr sz="1700">
+                <a:solidFill>
+                  <a:srgbClr val="E6E6E6"/>
+                </a:solidFill>
+              </a:rPr>
+              <a:t>• </a:t>
+            </a:r>
+            <a:r>
+              <a:rPr sz="1700" b="1">
+                <a:solidFill>
+                  <a:srgbClr val="FFAA3C"/>
+                </a:solidFill>
+              </a:rPr>
+              <a:t>LLM-as-Judge</a:t>
+            </a:r>
+            <a:r>
+              <a:rPr sz="1700">
+                <a:solidFill>
+                  <a:srgbClr val="E6E6E6"/>
+                </a:solidFill>
+              </a:rPr>
+              <a:t> — secondary model evaluates whether input attempts to subvert intended behavior</a:t>
+            </a:r>
+          </a:p>
+        </p:txBody>
+      </p:sp>
+      <p:sp>
+        <p:nvSpPr>
+          <p:cNvPr id="4" name="TextBox 3"/>
+          <p:cNvSpPr txBox="1"/>
+          <p:nvPr/>
+        </p:nvSpPr>
+        <p:spPr>
+          <a:xfrm>
+            <a:off x="731520" y="4114800"/>
+            <a:ext cx="10515600" cy="1371600"/>
+          </a:xfrm>
+          <a:prstGeom prst="rect">
+            <a:avLst/>
+          </a:prstGeom>
+          <a:noFill/>
+        </p:spPr>
+        <p:txBody>
+          <a:bodyPr wrap="square">
+            <a:spAutoFit/>
+          </a:bodyPr>
+          <a:lstStyle/>
+          <a:p>
+            <a:r>
+              <a:rPr sz="1400" b="1">
+                <a:solidFill>
+                  <a:srgbClr val="FFAA3C"/>
+                </a:solidFill>
+              </a:rPr>
+              <a:t>Tradeoff: </a:t>
+            </a:r>
+            <a:r>
+              <a:rPr sz="1400">
+                <a:solidFill>
+                  <a:srgbClr val="B4B4B4"/>
+                </a:solidFill>
+              </a:rPr>
+              <a:t>Smarter detection, but higher cost — LLM-as-judge adds latency and is itself vulnerable to injection</a:t>
+            </a:r>
+          </a:p>
+          <a:p>
+            <a:pPr>
+              <a:spcBef>
+                <a:spcPts val="1600"/>
+              </a:spcBef>
+            </a:pPr>
+            <a:r>
+              <a:rPr sz="1600" b="1">
+                <a:solidFill>
+                  <a:srgbClr val="64B4FF"/>
+                </a:solidFill>
+              </a:rPr>
+              <a:t>→ No single detection method is sufficient — defense in depth is required</a:t>
+            </a:r>
+          </a:p>
+        </p:txBody>
+      </p:sp>
+      <p:sp>
+        <p:nvSpPr>
+          <p:cNvPr id="5" name="TextBox 4"/>
+          <p:cNvSpPr txBox="1"/>
+          <p:nvPr/>
+        </p:nvSpPr>
+        <p:spPr>
+          <a:xfrm>
+            <a:off x="11247120" y="6400800"/>
+            <a:ext cx="731520" cy="365760"/>
+          </a:xfrm>
+          <a:prstGeom prst="rect">
+            <a:avLst/>
+          </a:prstGeom>
+          <a:noFill/>
+        </p:spPr>
+        <p:txBody>
+          <a:bodyPr wrap="square">
+            <a:spAutoFit/>
+          </a:bodyPr>
+          <a:lstStyle/>
+          <a:p>
+            <a:pPr algn="r">
+              <a:defRPr sz="1000" b="0">
+                <a:solidFill>
+                  <a:srgbClr val="8C8C8C"/>
+                </a:solidFill>
+              </a:defRPr>
+            </a:pPr>
+            <a:r>
+              <a:t>10</a:t>
+            </a:r>
+          </a:p>
+        </p:txBody>
+      </p:sp>
     </p:spTree>
   </p:cSld>
   <p:clrMapOvr>
@@ -4544,7 +4908,7 @@
               </a:defRPr>
             </a:pPr>
             <a:r>
-              <a:t>Prevention Strategies</a:t>
+              <a:t>Detection &amp; Defense Pipeline</a:t>
             </a:r>
           </a:p>
         </p:txBody>
@@ -4557,8 +4921,8 @@
         </p:nvSpPr>
         <p:spPr>
           <a:xfrm>
-            <a:off x="731520" y="1371600"/>
-            <a:ext cx="10515600" cy="4572000"/>
+            <a:off x="731520" y="1097280"/>
+            <a:ext cx="10515600" cy="365760"/>
           </a:xfrm>
           <a:prstGeom prst="rect">
             <a:avLst/>
@@ -4571,78 +4935,74 @@
           </a:bodyPr>
           <a:lstStyle/>
           <a:p>
-            <a:pPr>
-              <a:spcAft>
-                <a:spcPts val="600"/>
-              </a:spcAft>
-              <a:defRPr sz="1500">
-                <a:solidFill>
-                  <a:srgbClr val="E6E6E6"/>
+            <a:pPr algn="l">
+              <a:defRPr sz="1300" b="0">
+                <a:solidFill>
+                  <a:srgbClr val="8C8C8C"/>
                 </a:solidFill>
               </a:defRPr>
             </a:pPr>
             <a:r>
-              <a:t>• Instruction Hierarchy (model): Highly effective against naive direct injection ('ignore previous instructions') but partially bypas...</a:t>
-            </a:r>
-          </a:p>
-          <a:p>
-            <a:pPr>
-              <a:spcAft>
-                <a:spcPts val="600"/>
-              </a:spcAft>
-              <a:defRPr sz="1500">
-                <a:solidFill>
-                  <a:srgbClr val="E6E6E6"/>
+              <a:t>Multi-layered pipeline: input sanitization → detection → model processing → output filtering → monitoring</a:t>
+            </a:r>
+          </a:p>
+        </p:txBody>
+      </p:sp>
+      <p:pic>
+        <p:nvPicPr>
+          <p:cNvPr id="4" name="Picture 3" descr="defense_flow.png"/>
+          <p:cNvPicPr>
+            <a:picLocks noChangeAspect="1"/>
+          </p:cNvPicPr>
+          <p:nvPr/>
+        </p:nvPicPr>
+        <p:blipFill>
+          <a:blip r:embed="rId2"/>
+          <a:stretch>
+            <a:fillRect/>
+          </a:stretch>
+        </p:blipFill>
+        <p:spPr>
+          <a:xfrm>
+            <a:off x="1828800" y="1645920"/>
+            <a:ext cx="8229600" cy="4572000"/>
+          </a:xfrm>
+          <a:prstGeom prst="rect">
+            <a:avLst/>
+          </a:prstGeom>
+        </p:spPr>
+      </p:pic>
+      <p:sp>
+        <p:nvSpPr>
+          <p:cNvPr id="5" name="TextBox 4"/>
+          <p:cNvSpPr txBox="1"/>
+          <p:nvPr/>
+        </p:nvSpPr>
+        <p:spPr>
+          <a:xfrm>
+            <a:off x="11247120" y="6400800"/>
+            <a:ext cx="731520" cy="365760"/>
+          </a:xfrm>
+          <a:prstGeom prst="rect">
+            <a:avLst/>
+          </a:prstGeom>
+          <a:noFill/>
+        </p:spPr>
+        <p:txBody>
+          <a:bodyPr wrap="square">
+            <a:spAutoFit/>
+          </a:bodyPr>
+          <a:lstStyle/>
+          <a:p>
+            <a:pPr algn="r">
+              <a:defRPr sz="1000" b="0">
+                <a:solidFill>
+                  <a:srgbClr val="8C8C8C"/>
                 </a:solidFill>
               </a:defRPr>
             </a:pPr>
             <a:r>
-              <a:t>• Input Sanitization and Filtering (application): Reduces attack surface for known patterns but cannot provide complete protection due to the fundamen...</a:t>
-            </a:r>
-          </a:p>
-          <a:p>
-            <a:pPr>
-              <a:spcAft>
-                <a:spcPts val="600"/>
-              </a:spcAft>
-              <a:defRPr sz="1500">
-                <a:solidFill>
-                  <a:srgbClr val="E6E6E6"/>
-                </a:solidFill>
-              </a:defRPr>
-            </a:pPr>
-            <a:r>
-              <a:t>• Output Validation and Filtering (application): Effective as a safety net for detecting successful attacks that produce observable policy violations...</a:t>
-            </a:r>
-          </a:p>
-          <a:p>
-            <a:pPr>
-              <a:spcAft>
-                <a:spcPts val="600"/>
-              </a:spcAft>
-              <a:defRPr sz="1500">
-                <a:solidFill>
-                  <a:srgbClr val="E6E6E6"/>
-                </a:solidFill>
-              </a:defRPr>
-            </a:pPr>
-            <a:r>
-              <a:t>• Sandboxing and Isolation (system): Does not prevent injection but limits damage from successful attacks, making it a critical defense-i...</a:t>
-            </a:r>
-          </a:p>
-          <a:p>
-            <a:pPr>
-              <a:spcAft>
-                <a:spcPts val="600"/>
-              </a:spcAft>
-              <a:defRPr sz="1500">
-                <a:solidFill>
-                  <a:srgbClr val="E6E6E6"/>
-                </a:solidFill>
-              </a:defRPr>
-            </a:pPr>
-            <a:r>
-              <a:t>• Guardrail Frameworks (application): Provides structured, configurable defense that can be adapted per application without model-level ch...</a:t>
+              <a:t>11</a:t>
             </a:r>
           </a:p>
         </p:txBody>
@@ -4703,35 +5063,257 @@
               </a:defRPr>
             </a:pPr>
             <a:r>
-              <a:t>Layered Defense Architecture</a:t>
-            </a:r>
-          </a:p>
-        </p:txBody>
-      </p:sp>
-      <p:pic>
-        <p:nvPicPr>
-          <p:cNvPr id="3" name="Picture 2" descr="defense_architecture.png"/>
-          <p:cNvPicPr>
-            <a:picLocks noChangeAspect="1"/>
-          </p:cNvPicPr>
+              <a:t>Prevention Strategies</a:t>
+            </a:r>
+          </a:p>
+        </p:txBody>
+      </p:sp>
+      <p:sp>
+        <p:nvSpPr>
+          <p:cNvPr id="3" name="TextBox 2"/>
+          <p:cNvSpPr txBox="1"/>
           <p:nvPr/>
-        </p:nvPicPr>
-        <p:blipFill>
-          <a:blip r:embed="rId2"/>
-          <a:stretch>
-            <a:fillRect/>
-          </a:stretch>
-        </p:blipFill>
-        <p:spPr>
-          <a:xfrm>
-            <a:off x="1828800" y="1371600"/>
-            <a:ext cx="8229600" cy="4754880"/>
+        </p:nvSpPr>
+        <p:spPr>
+          <a:xfrm>
+            <a:off x="731520" y="1280160"/>
+            <a:ext cx="10515600" cy="4572000"/>
           </a:xfrm>
           <a:prstGeom prst="rect">
             <a:avLst/>
           </a:prstGeom>
-        </p:spPr>
-      </p:pic>
+          <a:noFill/>
+        </p:spPr>
+        <p:txBody>
+          <a:bodyPr wrap="square">
+            <a:spAutoFit/>
+          </a:bodyPr>
+          <a:lstStyle/>
+          <a:p>
+            <a:pPr>
+              <a:spcAft>
+                <a:spcPts val="800"/>
+              </a:spcAft>
+            </a:pPr>
+            <a:r>
+              <a:rPr sz="1600">
+                <a:solidFill>
+                  <a:srgbClr val="E6E6E6"/>
+                </a:solidFill>
+              </a:rPr>
+              <a:t>• </a:t>
+            </a:r>
+            <a:r>
+              <a:rPr sz="1600" b="1">
+                <a:solidFill>
+                  <a:srgbClr val="FFAA3C"/>
+                </a:solidFill>
+              </a:rPr>
+              <a:t>Instruction Hierarchy</a:t>
+            </a:r>
+            <a:r>
+              <a:rPr sz="1600">
+                <a:solidFill>
+                  <a:srgbClr val="E6E6E6"/>
+                </a:solidFill>
+              </a:rPr>
+              <a:t> — model-level privilege tiers — system &gt; user &gt; tool (Wallace et al., 2024)</a:t>
+            </a:r>
+          </a:p>
+          <a:p>
+            <a:pPr>
+              <a:spcAft>
+                <a:spcPts val="800"/>
+              </a:spcAft>
+            </a:pPr>
+            <a:r>
+              <a:rPr sz="1600">
+                <a:solidFill>
+                  <a:srgbClr val="E6E6E6"/>
+                </a:solidFill>
+              </a:rPr>
+              <a:t>• </a:t>
+            </a:r>
+            <a:r>
+              <a:rPr sz="1600" b="1">
+                <a:solidFill>
+                  <a:srgbClr val="FFAA3C"/>
+                </a:solidFill>
+              </a:rPr>
+              <a:t>Input Sanitization</a:t>
+            </a:r>
+            <a:r>
+              <a:rPr sz="1600">
+                <a:solidFill>
+                  <a:srgbClr val="E6E6E6"/>
+                </a:solidFill>
+              </a:rPr>
+              <a:t> — strip injection patterns, normalize Unicode, enforce length limits</a:t>
+            </a:r>
+          </a:p>
+          <a:p>
+            <a:pPr>
+              <a:spcAft>
+                <a:spcPts val="800"/>
+              </a:spcAft>
+            </a:pPr>
+            <a:r>
+              <a:rPr sz="1600">
+                <a:solidFill>
+                  <a:srgbClr val="E6E6E6"/>
+                </a:solidFill>
+              </a:rPr>
+              <a:t>• </a:t>
+            </a:r>
+            <a:r>
+              <a:rPr sz="1600" b="1">
+                <a:solidFill>
+                  <a:srgbClr val="FFAA3C"/>
+                </a:solidFill>
+              </a:rPr>
+              <a:t>Output Validation</a:t>
+            </a:r>
+            <a:r>
+              <a:rPr sz="1600">
+                <a:solidFill>
+                  <a:srgbClr val="E6E6E6"/>
+                </a:solidFill>
+              </a:rPr>
+              <a:t> — scan for data leakage, enforce format constraints, check canary tokens</a:t>
+            </a:r>
+          </a:p>
+          <a:p>
+            <a:pPr>
+              <a:spcAft>
+                <a:spcPts val="800"/>
+              </a:spcAft>
+            </a:pPr>
+            <a:r>
+              <a:rPr sz="1600">
+                <a:solidFill>
+                  <a:srgbClr val="E6E6E6"/>
+                </a:solidFill>
+              </a:rPr>
+              <a:t>• </a:t>
+            </a:r>
+            <a:r>
+              <a:rPr sz="1600" b="1">
+                <a:solidFill>
+                  <a:srgbClr val="FFAA3C"/>
+                </a:solidFill>
+              </a:rPr>
+              <a:t>Sandboxing &amp; Isolation</a:t>
+            </a:r>
+            <a:r>
+              <a:rPr sz="1600">
+                <a:solidFill>
+                  <a:srgbClr val="E6E6E6"/>
+                </a:solidFill>
+              </a:rPr>
+              <a:t> — least-privilege tool access, user approval gates for destructive actions</a:t>
+            </a:r>
+          </a:p>
+          <a:p>
+            <a:pPr>
+              <a:spcAft>
+                <a:spcPts val="800"/>
+              </a:spcAft>
+            </a:pPr>
+            <a:r>
+              <a:rPr sz="1600">
+                <a:solidFill>
+                  <a:srgbClr val="E6E6E6"/>
+                </a:solidFill>
+              </a:rPr>
+              <a:t>• </a:t>
+            </a:r>
+            <a:r>
+              <a:rPr sz="1600" b="1">
+                <a:solidFill>
+                  <a:srgbClr val="FFAA3C"/>
+                </a:solidFill>
+              </a:rPr>
+              <a:t>Guardrail Frameworks</a:t>
+            </a:r>
+            <a:r>
+              <a:rPr sz="1600">
+                <a:solidFill>
+                  <a:srgbClr val="E6E6E6"/>
+                </a:solidFill>
+              </a:rPr>
+              <a:t> — programmable middleware enforcing conversation policies (NeMo, Lakera)</a:t>
+            </a:r>
+          </a:p>
+        </p:txBody>
+      </p:sp>
+      <p:sp>
+        <p:nvSpPr>
+          <p:cNvPr id="4" name="TextBox 3"/>
+          <p:cNvSpPr txBox="1"/>
+          <p:nvPr/>
+        </p:nvSpPr>
+        <p:spPr>
+          <a:xfrm>
+            <a:off x="731520" y="5486400"/>
+            <a:ext cx="10515600" cy="548640"/>
+          </a:xfrm>
+          <a:prstGeom prst="rect">
+            <a:avLst/>
+          </a:prstGeom>
+          <a:noFill/>
+        </p:spPr>
+        <p:txBody>
+          <a:bodyPr wrap="none">
+            <a:spAutoFit/>
+          </a:bodyPr>
+          <a:lstStyle/>
+          <a:p>
+            <a:r>
+              <a:rPr sz="1400" b="1">
+                <a:solidFill>
+                  <a:srgbClr val="FFAA3C"/>
+                </a:solidFill>
+              </a:rPr>
+              <a:t>→ No single strategy is complete — layer instruction hierarchy + sanitization + output filtering</a:t>
+            </a:r>
+          </a:p>
+        </p:txBody>
+      </p:sp>
+      <p:sp>
+        <p:nvSpPr>
+          <p:cNvPr id="5" name="TextBox 4"/>
+          <p:cNvSpPr txBox="1"/>
+          <p:nvPr/>
+        </p:nvSpPr>
+        <p:spPr>
+          <a:xfrm>
+            <a:off x="11247120" y="6400800"/>
+            <a:ext cx="731520" cy="365760"/>
+          </a:xfrm>
+          <a:prstGeom prst="rect">
+            <a:avLst/>
+          </a:prstGeom>
+          <a:noFill/>
+        </p:spPr>
+        <p:txBody>
+          <a:bodyPr wrap="square">
+            <a:spAutoFit/>
+          </a:bodyPr>
+          <a:lstStyle/>
+          <a:p>
+            <a:pPr algn="r">
+              <a:defRPr sz="1000" b="0">
+                <a:solidFill>
+                  <a:srgbClr val="8C8C8C"/>
+                </a:solidFill>
+              </a:defRPr>
+            </a:pPr>
+            <a:r>
+              <a:t>12</a:t>
+            </a:r>
+          </a:p>
+        </p:txBody>
+      </p:sp>
     </p:spTree>
   </p:cSld>
   <p:clrMapOvr>
@@ -4788,7 +5370,7 @@
               </a:defRPr>
             </a:pPr>
             <a:r>
-              <a:t>Key References &amp; Conclusion</a:t>
+              <a:t>Layered Defense Architecture</a:t>
             </a:r>
           </a:p>
         </p:txBody>
@@ -4801,8 +5383,8 @@
         </p:nvSpPr>
         <p:spPr>
           <a:xfrm>
-            <a:off x="731520" y="1188720"/>
-            <a:ext cx="10515600" cy="4114800"/>
+            <a:off x="731520" y="1097280"/>
+            <a:ext cx="10515600" cy="365760"/>
           </a:xfrm>
           <a:prstGeom prst="rect">
             <a:avLst/>
@@ -4815,18 +5397,173 @@
           </a:bodyPr>
           <a:lstStyle/>
           <a:p>
+            <a:pPr algn="l">
+              <a:defRPr sz="1300" b="0">
+                <a:solidFill>
+                  <a:srgbClr val="8C8C8C"/>
+                </a:solidFill>
+              </a:defRPr>
+            </a:pPr>
+            <a:r>
+              <a:t>Model-level, application-level, and system-level controls working in coordination</a:t>
+            </a:r>
+          </a:p>
+        </p:txBody>
+      </p:sp>
+      <p:pic>
+        <p:nvPicPr>
+          <p:cNvPr id="4" name="Picture 3" descr="defense_architecture.png"/>
+          <p:cNvPicPr>
+            <a:picLocks noChangeAspect="1"/>
+          </p:cNvPicPr>
+          <p:nvPr/>
+        </p:nvPicPr>
+        <p:blipFill>
+          <a:blip r:embed="rId2"/>
+          <a:stretch>
+            <a:fillRect/>
+          </a:stretch>
+        </p:blipFill>
+        <p:spPr>
+          <a:xfrm>
+            <a:off x="1828800" y="1645920"/>
+            <a:ext cx="8229600" cy="4572000"/>
+          </a:xfrm>
+          <a:prstGeom prst="rect">
+            <a:avLst/>
+          </a:prstGeom>
+        </p:spPr>
+      </p:pic>
+      <p:sp>
+        <p:nvSpPr>
+          <p:cNvPr id="5" name="TextBox 4"/>
+          <p:cNvSpPr txBox="1"/>
+          <p:nvPr/>
+        </p:nvSpPr>
+        <p:spPr>
+          <a:xfrm>
+            <a:off x="11247120" y="6400800"/>
+            <a:ext cx="731520" cy="365760"/>
+          </a:xfrm>
+          <a:prstGeom prst="rect">
+            <a:avLst/>
+          </a:prstGeom>
+          <a:noFill/>
+        </p:spPr>
+        <p:txBody>
+          <a:bodyPr wrap="square">
+            <a:spAutoFit/>
+          </a:bodyPr>
+          <a:lstStyle/>
+          <a:p>
+            <a:pPr algn="r">
+              <a:defRPr sz="1000" b="0">
+                <a:solidFill>
+                  <a:srgbClr val="8C8C8C"/>
+                </a:solidFill>
+              </a:defRPr>
+            </a:pPr>
+            <a:r>
+              <a:t>13</a:t>
+            </a:r>
+          </a:p>
+        </p:txBody>
+      </p:sp>
+    </p:spTree>
+  </p:cSld>
+  <p:clrMapOvr>
+    <a:masterClrMapping/>
+  </p:clrMapOvr>
+</p:sld>
+</file>
+
+<file path=ppt/slides/slide14.xml><?xml version="1.0" encoding="utf-8"?>
+<p:sld xmlns:a="http://schemas.openxmlformats.org/drawingml/2006/main" xmlns:p="http://schemas.openxmlformats.org/presentationml/2006/main" xmlns:r="http://schemas.openxmlformats.org/officeDocument/2006/relationships">
+  <p:cSld>
+    <p:bg>
+      <p:bgPr>
+        <a:solidFill>
+          <a:srgbClr val="1E1E1E"/>
+        </a:solidFill>
+        <a:effectLst/>
+      </p:bgPr>
+    </p:bg>
+    <p:spTree>
+      <p:nvGrpSpPr>
+        <p:cNvPr id="1" name=""/>
+        <p:cNvGrpSpPr/>
+        <p:nvPr/>
+      </p:nvGrpSpPr>
+      <p:grpSpPr/>
+      <p:sp>
+        <p:nvSpPr>
+          <p:cNvPr id="2" name="TextBox 1"/>
+          <p:cNvSpPr txBox="1"/>
+          <p:nvPr/>
+        </p:nvSpPr>
+        <p:spPr>
+          <a:xfrm>
+            <a:off x="731520" y="365760"/>
+            <a:ext cx="10515600" cy="731520"/>
+          </a:xfrm>
+          <a:prstGeom prst="rect">
+            <a:avLst/>
+          </a:prstGeom>
+          <a:noFill/>
+        </p:spPr>
+        <p:txBody>
+          <a:bodyPr wrap="square">
+            <a:spAutoFit/>
+          </a:bodyPr>
+          <a:lstStyle/>
+          <a:p>
+            <a:pPr algn="l">
+              <a:defRPr sz="3200" b="1">
+                <a:solidFill>
+                  <a:srgbClr val="64B4FF"/>
+                </a:solidFill>
+              </a:defRPr>
+            </a:pPr>
+            <a:r>
+              <a:t>Key References</a:t>
+            </a:r>
+          </a:p>
+        </p:txBody>
+      </p:sp>
+      <p:sp>
+        <p:nvSpPr>
+          <p:cNvPr id="3" name="TextBox 2"/>
+          <p:cNvSpPr txBox="1"/>
+          <p:nvPr/>
+        </p:nvSpPr>
+        <p:spPr>
+          <a:xfrm>
+            <a:off x="731520" y="1188720"/>
+            <a:ext cx="10515600" cy="2743200"/>
+          </a:xfrm>
+          <a:prstGeom prst="rect">
+            <a:avLst/>
+          </a:prstGeom>
+          <a:noFill/>
+        </p:spPr>
+        <p:txBody>
+          <a:bodyPr wrap="square">
+            <a:spAutoFit/>
+          </a:bodyPr>
+          <a:lstStyle/>
+          <a:p>
             <a:pPr>
               <a:spcAft>
                 <a:spcPts val="600"/>
               </a:spcAft>
-              <a:defRPr sz="1300">
+              <a:defRPr sz="1400">
                 <a:solidFill>
                   <a:srgbClr val="E6E6E6"/>
                 </a:solidFill>
               </a:defRPr>
             </a:pPr>
             <a:r>
-              <a:t>• Abdallah, M., Barreno, A., Bensalah, F., et al. (2025). Prompt injection attacks in large language models and AI agent s...</a:t>
+              <a:t>• Abdallah, M., Barreno, A., Bensalah, F., et al. (2025). Prompt injection attacks in large language models and AI agent systems: A comprehensive review...</a:t>
             </a:r>
           </a:p>
           <a:p>
@@ -4834,14 +5571,14 @@
               <a:spcAft>
                 <a:spcPts val="600"/>
               </a:spcAft>
-              <a:defRPr sz="1300">
+              <a:defRPr sz="1400">
                 <a:solidFill>
                   <a:srgbClr val="E6E6E6"/>
                 </a:solidFill>
               </a:defRPr>
             </a:pPr>
             <a:r>
-              <a:t>• Ahmed, S., Kaur, K., &amp; Sharma, R. (2025). Prompt injection 2.0: Hybrid AI threats. arXiv. https://arxiv.org/abs/2507.131...</a:t>
+              <a:t>• Greshake, K., Abdelnabi, S., Mishra, S., Endres, C., Giner, T., &amp; Fritz, M. (2023). Not what you've signed up for: Compromising real-world LLM-integra...</a:t>
             </a:r>
           </a:p>
           <a:p>
@@ -4849,59 +5586,14 @@
               <a:spcAft>
                 <a:spcPts val="600"/>
               </a:spcAft>
-              <a:defRPr sz="1300">
+              <a:defRPr sz="1400">
                 <a:solidFill>
                   <a:srgbClr val="E6E6E6"/>
                 </a:solidFill>
               </a:defRPr>
             </a:pPr>
             <a:r>
-              <a:t>• Alon, G., &amp; Kamfonas, M. (2023). Detecting language model attacks with perplexity. arXiv. https://arxiv.org/abs/2308.141...</a:t>
-            </a:r>
-          </a:p>
-          <a:p>
-            <a:pPr>
-              <a:spcAft>
-                <a:spcPts val="600"/>
-              </a:spcAft>
-              <a:defRPr sz="1300">
-                <a:solidFill>
-                  <a:srgbClr val="E6E6E6"/>
-                </a:solidFill>
-              </a:defRPr>
-            </a:pPr>
-            <a:r>
-              <a:t>• Anthropic. (2024a). Research on AI safety and prompt security. Anthropic. https://www.anthropic.com/research</a:t>
-            </a:r>
-          </a:p>
-          <a:p>
-            <a:pPr>
-              <a:spcAft>
-                <a:spcPts val="600"/>
-              </a:spcAft>
-              <a:defRPr sz="1300">
-                <a:solidFill>
-                  <a:srgbClr val="E6E6E6"/>
-                </a:solidFill>
-              </a:defRPr>
-            </a:pPr>
-            <a:r>
-              <a:t>• Anthropic. (2024b). System prompt security best practices. Anthropic. https://docs.anthropic.com/en/docs/build-with-clau...</a:t>
-            </a:r>
-          </a:p>
-          <a:p>
-            <a:pPr>
-              <a:spcAft>
-                <a:spcPts val="600"/>
-              </a:spcAft>
-              <a:defRPr sz="1300">
-                <a:solidFill>
-                  <a:srgbClr val="E6E6E6"/>
-                </a:solidFill>
-              </a:defRPr>
-            </a:pPr>
-            <a:r>
-              <a:t>• BSG. (2025). OWASP LLM Top 10 (2025) analysis. BSG Tech Blog. https://bsg.tech/blog/owasp-llm-top-10/</a:t>
+              <a:t>• Wallace, E., Xiao, K., Leike, J., Weng, L., Heidecke, J., &amp; Beutel, A. (2024). The instruction hierarchy: Training LLMs to prioritize privileged instr...</a:t>
             </a:r>
           </a:p>
         </p:txBody>
@@ -4914,8 +5606,8 @@
         </p:nvSpPr>
         <p:spPr>
           <a:xfrm>
-            <a:off x="731520" y="5486400"/>
-            <a:ext cx="10515600" cy="731520"/>
+            <a:off x="731520" y="4114800"/>
+            <a:ext cx="10515600" cy="457200"/>
           </a:xfrm>
           <a:prstGeom prst="rect">
             <a:avLst/>
@@ -4929,14 +5621,254 @@
           <a:lstStyle/>
           <a:p>
             <a:pPr algn="l">
-              <a:defRPr sz="2000" b="1">
-                <a:solidFill>
-                  <a:srgbClr val="FFAA3C"/>
+              <a:defRPr sz="1200" b="0">
+                <a:solidFill>
+                  <a:srgbClr val="8C8C8C"/>
                 </a:solidFill>
               </a:defRPr>
             </a:pPr>
             <a:r>
-              <a:t>Prompt injection remains an open problem — defense in depth is essential.</a:t>
+              <a:t>Full reference list: 18 sources spanning academic papers, industry reports, and government standards (2023–2025)</a:t>
+            </a:r>
+          </a:p>
+        </p:txBody>
+      </p:sp>
+      <p:sp>
+        <p:nvSpPr>
+          <p:cNvPr id="5" name="TextBox 4"/>
+          <p:cNvSpPr txBox="1"/>
+          <p:nvPr/>
+        </p:nvSpPr>
+        <p:spPr>
+          <a:xfrm>
+            <a:off x="731520" y="4846320"/>
+            <a:ext cx="10515600" cy="1097280"/>
+          </a:xfrm>
+          <a:prstGeom prst="rect">
+            <a:avLst/>
+          </a:prstGeom>
+          <a:noFill/>
+        </p:spPr>
+        <p:txBody>
+          <a:bodyPr wrap="square">
+            <a:spAutoFit/>
+          </a:bodyPr>
+          <a:lstStyle/>
+          <a:p>
+            <a:pPr algn="l"/>
+            <a:r>
+              <a:rPr sz="2400" b="1">
+                <a:solidFill>
+                  <a:srgbClr val="FFAA3C"/>
+                </a:solidFill>
+              </a:rPr>
+              <a:t>Prompt injection remains an open problem —
+defense in depth is essential.</a:t>
+            </a:r>
+          </a:p>
+        </p:txBody>
+      </p:sp>
+      <p:sp>
+        <p:nvSpPr>
+          <p:cNvPr id="6" name="TextBox 5"/>
+          <p:cNvSpPr txBox="1"/>
+          <p:nvPr/>
+        </p:nvSpPr>
+        <p:spPr>
+          <a:xfrm>
+            <a:off x="11247120" y="6400800"/>
+            <a:ext cx="731520" cy="365760"/>
+          </a:xfrm>
+          <a:prstGeom prst="rect">
+            <a:avLst/>
+          </a:prstGeom>
+          <a:noFill/>
+        </p:spPr>
+        <p:txBody>
+          <a:bodyPr wrap="square">
+            <a:spAutoFit/>
+          </a:bodyPr>
+          <a:lstStyle/>
+          <a:p>
+            <a:pPr algn="r">
+              <a:defRPr sz="1000" b="0">
+                <a:solidFill>
+                  <a:srgbClr val="8C8C8C"/>
+                </a:solidFill>
+              </a:defRPr>
+            </a:pPr>
+            <a:r>
+              <a:t>14</a:t>
+            </a:r>
+          </a:p>
+        </p:txBody>
+      </p:sp>
+    </p:spTree>
+  </p:cSld>
+  <p:clrMapOvr>
+    <a:masterClrMapping/>
+  </p:clrMapOvr>
+</p:sld>
+</file>
+
+<file path=ppt/slides/slide15.xml><?xml version="1.0" encoding="utf-8"?>
+<p:sld xmlns:a="http://schemas.openxmlformats.org/drawingml/2006/main" xmlns:p="http://schemas.openxmlformats.org/presentationml/2006/main" xmlns:r="http://schemas.openxmlformats.org/officeDocument/2006/relationships">
+  <p:cSld>
+    <p:bg>
+      <p:bgPr>
+        <a:solidFill>
+          <a:srgbClr val="1E1E1E"/>
+        </a:solidFill>
+        <a:effectLst/>
+      </p:bgPr>
+    </p:bg>
+    <p:spTree>
+      <p:nvGrpSpPr>
+        <p:cNvPr id="1" name=""/>
+        <p:cNvGrpSpPr/>
+        <p:nvPr/>
+      </p:nvGrpSpPr>
+      <p:grpSpPr/>
+      <p:sp>
+        <p:nvSpPr>
+          <p:cNvPr id="2" name="TextBox 1"/>
+          <p:cNvSpPr txBox="1"/>
+          <p:nvPr/>
+        </p:nvSpPr>
+        <p:spPr>
+          <a:xfrm>
+            <a:off x="914400" y="1828800"/>
+            <a:ext cx="10058400" cy="1828800"/>
+          </a:xfrm>
+          <a:prstGeom prst="rect">
+            <a:avLst/>
+          </a:prstGeom>
+          <a:noFill/>
+        </p:spPr>
+        <p:txBody>
+          <a:bodyPr wrap="square">
+            <a:spAutoFit/>
+          </a:bodyPr>
+          <a:lstStyle/>
+          <a:p>
+            <a:pPr algn="ctr">
+              <a:defRPr sz="4800" b="1">
+                <a:solidFill>
+                  <a:srgbClr val="64B4FF"/>
+                </a:solidFill>
+              </a:defRPr>
+            </a:pPr>
+            <a:r>
+              <a:t>Questions?</a:t>
+            </a:r>
+          </a:p>
+        </p:txBody>
+      </p:sp>
+      <p:sp>
+        <p:nvSpPr>
+          <p:cNvPr id="3" name="TextBox 2"/>
+          <p:cNvSpPr txBox="1"/>
+          <p:nvPr/>
+        </p:nvSpPr>
+        <p:spPr>
+          <a:xfrm>
+            <a:off x="914400" y="3840480"/>
+            <a:ext cx="10058400" cy="914400"/>
+          </a:xfrm>
+          <a:prstGeom prst="rect">
+            <a:avLst/>
+          </a:prstGeom>
+          <a:noFill/>
+        </p:spPr>
+        <p:txBody>
+          <a:bodyPr wrap="square">
+            <a:spAutoFit/>
+          </a:bodyPr>
+          <a:lstStyle/>
+          <a:p>
+            <a:pPr algn="ctr">
+              <a:defRPr sz="1800" b="0">
+                <a:solidFill>
+                  <a:srgbClr val="B4B4B4"/>
+                </a:solidFill>
+              </a:defRPr>
+            </a:pPr>
+            <a:r>
+              <a:t>Prompt injection is the #1 LLM vulnerability — no single defense is sufficient,</a:t>
+            </a:r>
+            <a:br/>
+            <a:r>
+              <a:t>but layered strategies provide meaningful risk reduction.</a:t>
+            </a:r>
+          </a:p>
+        </p:txBody>
+      </p:sp>
+      <p:sp>
+        <p:nvSpPr>
+          <p:cNvPr id="4" name="TextBox 3"/>
+          <p:cNvSpPr txBox="1"/>
+          <p:nvPr/>
+        </p:nvSpPr>
+        <p:spPr>
+          <a:xfrm>
+            <a:off x="914400" y="5303520"/>
+            <a:ext cx="10058400" cy="548640"/>
+          </a:xfrm>
+          <a:prstGeom prst="rect">
+            <a:avLst/>
+          </a:prstGeom>
+          <a:noFill/>
+        </p:spPr>
+        <p:txBody>
+          <a:bodyPr wrap="square">
+            <a:spAutoFit/>
+          </a:bodyPr>
+          <a:lstStyle/>
+          <a:p>
+            <a:pPr algn="ctr">
+              <a:defRPr sz="1400" b="0">
+                <a:solidFill>
+                  <a:srgbClr val="8C8C8C"/>
+                </a:solidFill>
+              </a:defRPr>
+            </a:pPr>
+            <a:r>
+              <a:t>Edward Griggs • Christopher Newport University • COVACCI</a:t>
+            </a:r>
+          </a:p>
+        </p:txBody>
+      </p:sp>
+      <p:sp>
+        <p:nvSpPr>
+          <p:cNvPr id="5" name="TextBox 4"/>
+          <p:cNvSpPr txBox="1"/>
+          <p:nvPr/>
+        </p:nvSpPr>
+        <p:spPr>
+          <a:xfrm>
+            <a:off x="11247120" y="6400800"/>
+            <a:ext cx="731520" cy="365760"/>
+          </a:xfrm>
+          <a:prstGeom prst="rect">
+            <a:avLst/>
+          </a:prstGeom>
+          <a:noFill/>
+        </p:spPr>
+        <p:txBody>
+          <a:bodyPr wrap="square">
+            <a:spAutoFit/>
+          </a:bodyPr>
+          <a:lstStyle/>
+          <a:p>
+            <a:pPr algn="r">
+              <a:defRPr sz="1000" b="0">
+                <a:solidFill>
+                  <a:srgbClr val="8C8C8C"/>
+                </a:solidFill>
+              </a:defRPr>
+            </a:pPr>
+            <a:r>
+              <a:t>15</a:t>
             </a:r>
           </a:p>
         </p:txBody>
@@ -5115,6 +6047,41 @@
           </a:p>
         </p:txBody>
       </p:sp>
+      <p:sp>
+        <p:nvSpPr>
+          <p:cNvPr id="4" name="TextBox 3"/>
+          <p:cNvSpPr txBox="1"/>
+          <p:nvPr/>
+        </p:nvSpPr>
+        <p:spPr>
+          <a:xfrm>
+            <a:off x="11247120" y="6400800"/>
+            <a:ext cx="731520" cy="365760"/>
+          </a:xfrm>
+          <a:prstGeom prst="rect">
+            <a:avLst/>
+          </a:prstGeom>
+          <a:noFill/>
+        </p:spPr>
+        <p:txBody>
+          <a:bodyPr wrap="square">
+            <a:spAutoFit/>
+          </a:bodyPr>
+          <a:lstStyle/>
+          <a:p>
+            <a:pPr algn="r">
+              <a:defRPr sz="1000" b="0">
+                <a:solidFill>
+                  <a:srgbClr val="8C8C8C"/>
+                </a:solidFill>
+              </a:defRPr>
+            </a:pPr>
+            <a:r>
+              <a:t>2</a:t>
+            </a:r>
+          </a:p>
+        </p:txBody>
+      </p:sp>
     </p:spTree>
   </p:cSld>
   <p:clrMapOvr>
@@ -5185,7 +6152,7 @@
         <p:spPr>
           <a:xfrm>
             <a:off x="731520" y="1371600"/>
-            <a:ext cx="10515600" cy="4572000"/>
+            <a:ext cx="7315200" cy="4572000"/>
           </a:xfrm>
           <a:prstGeom prst="rect">
             <a:avLst/>
@@ -5202,7 +6169,7 @@
               <a:spcAft>
                 <a:spcPts val="600"/>
               </a:spcAft>
-              <a:defRPr sz="1800">
+              <a:defRPr sz="1700">
                 <a:solidFill>
                   <a:srgbClr val="E6E6E6"/>
                 </a:solidFill>
@@ -5217,7 +6184,7 @@
               <a:spcAft>
                 <a:spcPts val="600"/>
               </a:spcAft>
-              <a:defRPr sz="1800">
+              <a:defRPr sz="1700">
                 <a:solidFill>
                   <a:srgbClr val="E6E6E6"/>
                 </a:solidFill>
@@ -5232,14 +6199,14 @@
               <a:spcAft>
                 <a:spcPts val="600"/>
               </a:spcAft>
-              <a:defRPr sz="1800">
+              <a:defRPr sz="1700">
                 <a:solidFill>
                   <a:srgbClr val="E6E6E6"/>
                 </a:solidFill>
               </a:defRPr>
             </a:pPr>
             <a:r>
-              <a:t>• Ranked #1 on the OWASP Top 10 for LLM Applications (LLM01)</a:t>
+              <a:t>• Affects all major LLM platforms: ChatGPT, Claude, Gemini, Copilot</a:t>
             </a:r>
           </a:p>
           <a:p>
@@ -5247,29 +6214,106 @@
               <a:spcAft>
                 <a:spcPts val="600"/>
               </a:spcAft>
-              <a:defRPr sz="1800">
+              <a:defRPr sz="1700">
                 <a:solidFill>
                   <a:srgbClr val="E6E6E6"/>
                 </a:solidFill>
               </a:defRPr>
             </a:pPr>
             <a:r>
-              <a:t>• Affects all major LLM platforms: ChatGPT, Claude, Gemini, Copilot</a:t>
-            </a:r>
-          </a:p>
-          <a:p>
-            <a:pPr>
-              <a:spcAft>
-                <a:spcPts val="600"/>
-              </a:spcAft>
-              <a:defRPr sz="1800">
-                <a:solidFill>
-                  <a:srgbClr val="E6E6E6"/>
+              <a:t>• Two primary vectors: direct injection (user input) and indirect injection (external data)</a:t>
+            </a:r>
+          </a:p>
+        </p:txBody>
+      </p:sp>
+      <p:sp>
+        <p:nvSpPr>
+          <p:cNvPr id="4" name="TextBox 3"/>
+          <p:cNvSpPr txBox="1"/>
+          <p:nvPr/>
+        </p:nvSpPr>
+        <p:spPr>
+          <a:xfrm>
+            <a:off x="8686800" y="1645920"/>
+            <a:ext cx="2743200" cy="1828800"/>
+          </a:xfrm>
+          <a:prstGeom prst="rect">
+            <a:avLst/>
+          </a:prstGeom>
+          <a:noFill/>
+        </p:spPr>
+        <p:txBody>
+          <a:bodyPr wrap="square">
+            <a:spAutoFit/>
+          </a:bodyPr>
+          <a:lstStyle/>
+          <a:p>
+            <a:pPr algn="ctr"/>
+            <a:r>
+              <a:rPr sz="7200" b="1">
+                <a:solidFill>
+                  <a:srgbClr val="FF5050"/>
+                </a:solidFill>
+              </a:rPr>
+              <a:t>#1</a:t>
+            </a:r>
+          </a:p>
+          <a:p>
+            <a:pPr algn="ctr"/>
+            <a:r>
+              <a:rPr sz="1400" b="1">
+                <a:solidFill>
+                  <a:srgbClr val="FFAA3C"/>
+                </a:solidFill>
+              </a:rPr>
+              <a:t>OWASP Top 10
+for LLM Apps</a:t>
+            </a:r>
+          </a:p>
+          <a:p>
+            <a:pPr algn="ctr"/>
+            <a:r>
+              <a:rPr sz="1200">
+                <a:solidFill>
+                  <a:srgbClr val="B4B4B4"/>
+                </a:solidFill>
+              </a:rPr>
+              <a:t>(LLM01)</a:t>
+            </a:r>
+          </a:p>
+        </p:txBody>
+      </p:sp>
+      <p:sp>
+        <p:nvSpPr>
+          <p:cNvPr id="5" name="TextBox 4"/>
+          <p:cNvSpPr txBox="1"/>
+          <p:nvPr/>
+        </p:nvSpPr>
+        <p:spPr>
+          <a:xfrm>
+            <a:off x="11247120" y="6400800"/>
+            <a:ext cx="731520" cy="365760"/>
+          </a:xfrm>
+          <a:prstGeom prst="rect">
+            <a:avLst/>
+          </a:prstGeom>
+          <a:noFill/>
+        </p:spPr>
+        <p:txBody>
+          <a:bodyPr wrap="square">
+            <a:spAutoFit/>
+          </a:bodyPr>
+          <a:lstStyle/>
+          <a:p>
+            <a:pPr algn="r">
+              <a:defRPr sz="1000" b="0">
+                <a:solidFill>
+                  <a:srgbClr val="8C8C8C"/>
                 </a:solidFill>
               </a:defRPr>
             </a:pPr>
             <a:r>
-              <a:t>• Two primary vectors: direct injection (user input) and indirect injection (external data)</a:t>
+              <a:t>3</a:t>
             </a:r>
           </a:p>
         </p:txBody>
@@ -5359,46 +6403,164 @@
           <a:p>
             <a:pPr>
               <a:spcAft>
-                <a:spcPts val="600"/>
+                <a:spcPts val="800"/>
               </a:spcAft>
-              <a:defRPr sz="1600">
+            </a:pPr>
+            <a:r>
+              <a:rPr sz="1800">
                 <a:solidFill>
                   <a:srgbClr val="E6E6E6"/>
+                </a:solidFill>
+              </a:rPr>
+              <a:t>• </a:t>
+            </a:r>
+            <a:r>
+              <a:rPr sz="1800" b="1">
+                <a:solidFill>
+                  <a:srgbClr val="FFAA3C"/>
+                </a:solidFill>
+              </a:rPr>
+              <a:t>Jailbreaking</a:t>
+            </a:r>
+            <a:r>
+              <a:rPr sz="1800">
+                <a:solidFill>
+                  <a:srgbClr val="E6E6E6"/>
+                </a:solidFill>
+              </a:rPr>
+              <a:t> — persona manipulation bypasses safety alignment (DAN, role-play scenarios)</a:t>
+            </a:r>
+          </a:p>
+          <a:p>
+            <a:pPr>
+              <a:spcAft>
+                <a:spcPts val="800"/>
+              </a:spcAft>
+            </a:pPr>
+            <a:r>
+              <a:rPr sz="1800">
+                <a:solidFill>
+                  <a:srgbClr val="E6E6E6"/>
+                </a:solidFill>
+              </a:rPr>
+              <a:t>• </a:t>
+            </a:r>
+            <a:r>
+              <a:rPr sz="1800" b="1">
+                <a:solidFill>
+                  <a:srgbClr val="FFAA3C"/>
+                </a:solidFill>
+              </a:rPr>
+              <a:t>Goal Hijacking</a:t>
+            </a:r>
+            <a:r>
+              <a:rPr sz="1800">
+                <a:solidFill>
+                  <a:srgbClr val="E6E6E6"/>
+                </a:solidFill>
+              </a:rPr>
+              <a:t> — redirects model objective via competing instructions ('ignore previous...')</a:t>
+            </a:r>
+          </a:p>
+          <a:p>
+            <a:pPr>
+              <a:spcAft>
+                <a:spcPts val="800"/>
+              </a:spcAft>
+            </a:pPr>
+            <a:r>
+              <a:rPr sz="1800">
+                <a:solidFill>
+                  <a:srgbClr val="E6E6E6"/>
+                </a:solidFill>
+              </a:rPr>
+              <a:t>• </a:t>
+            </a:r>
+            <a:r>
+              <a:rPr sz="1800" b="1">
+                <a:solidFill>
+                  <a:srgbClr val="FFAA3C"/>
+                </a:solidFill>
+              </a:rPr>
+              <a:t>Prompt Leaking</a:t>
+            </a:r>
+            <a:r>
+              <a:rPr sz="1800">
+                <a:solidFill>
+                  <a:srgbClr val="E6E6E6"/>
+                </a:solidFill>
+              </a:rPr>
+              <a:t> — extracts system prompts, revealing guardrails for targeted follow-up attacks</a:t>
+            </a:r>
+          </a:p>
+        </p:txBody>
+      </p:sp>
+      <p:sp>
+        <p:nvSpPr>
+          <p:cNvPr id="4" name="TextBox 3"/>
+          <p:cNvSpPr txBox="1"/>
+          <p:nvPr/>
+        </p:nvSpPr>
+        <p:spPr>
+          <a:xfrm>
+            <a:off x="731520" y="5029200"/>
+            <a:ext cx="10515600" cy="731520"/>
+          </a:xfrm>
+          <a:prstGeom prst="rect">
+            <a:avLst/>
+          </a:prstGeom>
+          <a:noFill/>
+        </p:spPr>
+        <p:txBody>
+          <a:bodyPr wrap="square">
+            <a:spAutoFit/>
+          </a:bodyPr>
+          <a:lstStyle/>
+          <a:p>
+            <a:pPr algn="l">
+              <a:defRPr sz="1300" b="0">
+                <a:solidFill>
+                  <a:srgbClr val="8C8C8C"/>
                 </a:solidFill>
               </a:defRPr>
             </a:pPr>
             <a:r>
-              <a:t>• Jailbreaking: Techniques that bypass safety alignment through role-play scenarios, hypothetical framing, or persona manipulation. The ...</a:t>
-            </a:r>
-          </a:p>
-          <a:p>
-            <a:pPr>
-              <a:spcAft>
-                <a:spcPts val="600"/>
-              </a:spcAft>
-              <a:defRPr sz="1600">
-                <a:solidFill>
-                  <a:srgbClr val="E6E6E6"/>
+              <a:t>Earliest and most widely studied class — exploits the inability to distinguish instructions from data</a:t>
+            </a:r>
+          </a:p>
+        </p:txBody>
+      </p:sp>
+      <p:sp>
+        <p:nvSpPr>
+          <p:cNvPr id="5" name="TextBox 4"/>
+          <p:cNvSpPr txBox="1"/>
+          <p:nvPr/>
+        </p:nvSpPr>
+        <p:spPr>
+          <a:xfrm>
+            <a:off x="11247120" y="6400800"/>
+            <a:ext cx="731520" cy="365760"/>
+          </a:xfrm>
+          <a:prstGeom prst="rect">
+            <a:avLst/>
+          </a:prstGeom>
+          <a:noFill/>
+        </p:spPr>
+        <p:txBody>
+          <a:bodyPr wrap="square">
+            <a:spAutoFit/>
+          </a:bodyPr>
+          <a:lstStyle/>
+          <a:p>
+            <a:pPr algn="r">
+              <a:defRPr sz="1000" b="0">
+                <a:solidFill>
+                  <a:srgbClr val="8C8C8C"/>
                 </a:solidFill>
               </a:defRPr>
             </a:pPr>
             <a:r>
-              <a:t>• Goal Hijacking: Instructions that redirect the model's objective away from the system-defined task toward an attacker-chosen goal. Unlik...</a:t>
-            </a:r>
-          </a:p>
-          <a:p>
-            <a:pPr>
-              <a:spcAft>
-                <a:spcPts val="600"/>
-              </a:spcAft>
-              <a:defRPr sz="1600">
-                <a:solidFill>
-                  <a:srgbClr val="E6E6E6"/>
-                </a:solidFill>
-              </a:defRPr>
-            </a:pPr>
-            <a:r>
-              <a:t>• Prompt Leaking: Attacks designed to extract the system prompt or other confidential instructions embedded in the model's context. Succes...</a:t>
+              <a:t>4</a:t>
             </a:r>
           </a:p>
         </p:txBody>
@@ -5488,46 +6650,164 @@
           <a:p>
             <a:pPr>
               <a:spcAft>
-                <a:spcPts val="600"/>
+                <a:spcPts val="800"/>
               </a:spcAft>
-              <a:defRPr sz="1600">
+            </a:pPr>
+            <a:r>
+              <a:rPr sz="1800">
                 <a:solidFill>
                   <a:srgbClr val="E6E6E6"/>
+                </a:solidFill>
+              </a:rPr>
+              <a:t>• </a:t>
+            </a:r>
+            <a:r>
+              <a:rPr sz="1800" b="1">
+                <a:solidFill>
+                  <a:srgbClr val="FFAA3C"/>
+                </a:solidFill>
+              </a:rPr>
+              <a:t>RAG Poisoning</a:t>
+            </a:r>
+            <a:r>
+              <a:rPr sz="1800">
+                <a:solidFill>
+                  <a:srgbClr val="E6E6E6"/>
+                </a:solidFill>
+              </a:rPr>
+              <a:t> — malicious instructions in knowledge base documents execute on retrieval</a:t>
+            </a:r>
+          </a:p>
+          <a:p>
+            <a:pPr>
+              <a:spcAft>
+                <a:spcPts val="800"/>
+              </a:spcAft>
+            </a:pPr>
+            <a:r>
+              <a:rPr sz="1800">
+                <a:solidFill>
+                  <a:srgbClr val="E6E6E6"/>
+                </a:solidFill>
+              </a:rPr>
+              <a:t>• </a:t>
+            </a:r>
+            <a:r>
+              <a:rPr sz="1800" b="1">
+                <a:solidFill>
+                  <a:srgbClr val="FFAA3C"/>
+                </a:solidFill>
+              </a:rPr>
+              <a:t>Web Content Injection</a:t>
+            </a:r>
+            <a:r>
+              <a:rPr sz="1800">
+                <a:solidFill>
+                  <a:srgbClr val="E6E6E6"/>
+                </a:solidFill>
+              </a:rPr>
+              <a:t> — hidden payloads in web pages target LLM browsing agents and summarizers</a:t>
+            </a:r>
+          </a:p>
+          <a:p>
+            <a:pPr>
+              <a:spcAft>
+                <a:spcPts val="800"/>
+              </a:spcAft>
+            </a:pPr>
+            <a:r>
+              <a:rPr sz="1800">
+                <a:solidFill>
+                  <a:srgbClr val="E6E6E6"/>
+                </a:solidFill>
+              </a:rPr>
+              <a:t>• </a:t>
+            </a:r>
+            <a:r>
+              <a:rPr sz="1800" b="1">
+                <a:solidFill>
+                  <a:srgbClr val="FFAA3C"/>
+                </a:solidFill>
+              </a:rPr>
+              <a:t>Email &amp; Document Injection</a:t>
+            </a:r>
+            <a:r>
+              <a:rPr sz="1800">
+                <a:solidFill>
+                  <a:srgbClr val="E6E6E6"/>
+                </a:solidFill>
+              </a:rPr>
+              <a:t> — instructions in emails/PDFs trigger unauthorized AI assistant actions</a:t>
+            </a:r>
+          </a:p>
+        </p:txBody>
+      </p:sp>
+      <p:sp>
+        <p:nvSpPr>
+          <p:cNvPr id="4" name="TextBox 3"/>
+          <p:cNvSpPr txBox="1"/>
+          <p:nvPr/>
+        </p:nvSpPr>
+        <p:spPr>
+          <a:xfrm>
+            <a:off x="731520" y="5029200"/>
+            <a:ext cx="10515600" cy="731520"/>
+          </a:xfrm>
+          <a:prstGeom prst="rect">
+            <a:avLst/>
+          </a:prstGeom>
+          <a:noFill/>
+        </p:spPr>
+        <p:txBody>
+          <a:bodyPr wrap="square">
+            <a:spAutoFit/>
+          </a:bodyPr>
+          <a:lstStyle/>
+          <a:p>
+            <a:pPr algn="l">
+              <a:defRPr sz="1300" b="0">
+                <a:solidFill>
+                  <a:srgbClr val="8C8C8C"/>
                 </a:solidFill>
               </a:defRPr>
             </a:pPr>
             <a:r>
-              <a:t>• RAG Poisoning: Injecting malicious instructions into documents stored in retrieval-augmented generation knowledge bases. When the poiso...</a:t>
-            </a:r>
-          </a:p>
-          <a:p>
-            <a:pPr>
-              <a:spcAft>
-                <a:spcPts val="600"/>
-              </a:spcAft>
-              <a:defRPr sz="1600">
-                <a:solidFill>
-                  <a:srgbClr val="E6E6E6"/>
+              <a:t>Most dangerous vector for LLM-integrated apps — attacker never interacts with the model directly (Greshake et al., 2023)</a:t>
+            </a:r>
+          </a:p>
+        </p:txBody>
+      </p:sp>
+      <p:sp>
+        <p:nvSpPr>
+          <p:cNvPr id="5" name="TextBox 4"/>
+          <p:cNvSpPr txBox="1"/>
+          <p:nvPr/>
+        </p:nvSpPr>
+        <p:spPr>
+          <a:xfrm>
+            <a:off x="11247120" y="6400800"/>
+            <a:ext cx="731520" cy="365760"/>
+          </a:xfrm>
+          <a:prstGeom prst="rect">
+            <a:avLst/>
+          </a:prstGeom>
+          <a:noFill/>
+        </p:spPr>
+        <p:txBody>
+          <a:bodyPr wrap="square">
+            <a:spAutoFit/>
+          </a:bodyPr>
+          <a:lstStyle/>
+          <a:p>
+            <a:pPr algn="r">
+              <a:defRPr sz="1000" b="0">
+                <a:solidFill>
+                  <a:srgbClr val="8C8C8C"/>
                 </a:solidFill>
               </a:defRPr>
             </a:pPr>
             <a:r>
-              <a:t>• Web Content Injection: Embedding prompt injection payloads in web pages that LLM-powered browsing agents or summarizers will process. The paylo...</a:t>
-            </a:r>
-          </a:p>
-          <a:p>
-            <a:pPr>
-              <a:spcAft>
-                <a:spcPts val="600"/>
-              </a:spcAft>
-              <a:defRPr sz="1600">
-                <a:solidFill>
-                  <a:srgbClr val="E6E6E6"/>
-                </a:solidFill>
-              </a:defRPr>
-            </a:pPr>
-            <a:r>
-              <a:t>• Email and Document Injection: Malicious instructions placed in emails, PDFs, spreadsheets, or other documents that LLM assistants process. When an AI ...</a:t>
+              <a:t>5</a:t>
             </a:r>
           </a:p>
         </p:txBody>
@@ -5593,9 +6873,44 @@
           </a:p>
         </p:txBody>
       </p:sp>
+      <p:sp>
+        <p:nvSpPr>
+          <p:cNvPr id="3" name="TextBox 2"/>
+          <p:cNvSpPr txBox="1"/>
+          <p:nvPr/>
+        </p:nvSpPr>
+        <p:spPr>
+          <a:xfrm>
+            <a:off x="731520" y="1097280"/>
+            <a:ext cx="10515600" cy="365760"/>
+          </a:xfrm>
+          <a:prstGeom prst="rect">
+            <a:avLst/>
+          </a:prstGeom>
+          <a:noFill/>
+        </p:spPr>
+        <p:txBody>
+          <a:bodyPr wrap="square">
+            <a:spAutoFit/>
+          </a:bodyPr>
+          <a:lstStyle/>
+          <a:p>
+            <a:pPr algn="l">
+              <a:defRPr sz="1300" b="0">
+                <a:solidFill>
+                  <a:srgbClr val="8C8C8C"/>
+                </a:solidFill>
+              </a:defRPr>
+            </a:pPr>
+            <a:r>
+              <a:t>Six categories progressing from well-understood (direct) to emerging threats (autonomous propagation)</a:t>
+            </a:r>
+          </a:p>
+        </p:txBody>
+      </p:sp>
       <p:pic>
         <p:nvPicPr>
-          <p:cNvPr id="3" name="Picture 2" descr="attack_taxonomy.png"/>
+          <p:cNvPr id="4" name="Picture 3" descr="attack_taxonomy.png"/>
           <p:cNvPicPr>
             <a:picLocks noChangeAspect="1"/>
           </p:cNvPicPr>
@@ -5609,14 +6924,49 @@
         </p:blipFill>
         <p:spPr>
           <a:xfrm>
-            <a:off x="1828800" y="1371600"/>
-            <a:ext cx="8229600" cy="4754880"/>
+            <a:off x="1828800" y="1645920"/>
+            <a:ext cx="8229600" cy="4572000"/>
           </a:xfrm>
           <a:prstGeom prst="rect">
             <a:avLst/>
           </a:prstGeom>
         </p:spPr>
       </p:pic>
+      <p:sp>
+        <p:nvSpPr>
+          <p:cNvPr id="5" name="TextBox 4"/>
+          <p:cNvSpPr txBox="1"/>
+          <p:nvPr/>
+        </p:nvSpPr>
+        <p:spPr>
+          <a:xfrm>
+            <a:off x="11247120" y="6400800"/>
+            <a:ext cx="731520" cy="365760"/>
+          </a:xfrm>
+          <a:prstGeom prst="rect">
+            <a:avLst/>
+          </a:prstGeom>
+          <a:noFill/>
+        </p:spPr>
+        <p:txBody>
+          <a:bodyPr wrap="square">
+            <a:spAutoFit/>
+          </a:bodyPr>
+          <a:lstStyle/>
+          <a:p>
+            <a:pPr algn="r">
+              <a:defRPr sz="1000" b="0">
+                <a:solidFill>
+                  <a:srgbClr val="8C8C8C"/>
+                </a:solidFill>
+              </a:defRPr>
+            </a:pPr>
+            <a:r>
+              <a:t>6</a:t>
+            </a:r>
+          </a:p>
+        </p:txBody>
+      </p:sp>
     </p:spTree>
   </p:cSld>
   <p:clrMapOvr>
@@ -5702,46 +7052,162 @@
           <a:p>
             <a:pPr>
               <a:spcAft>
-                <a:spcPts val="600"/>
+                <a:spcPts val="800"/>
               </a:spcAft>
-              <a:defRPr sz="1600">
+            </a:pPr>
+            <a:r>
+              <a:rPr sz="1700">
                 <a:solidFill>
                   <a:srgbClr val="E6E6E6"/>
+                </a:solidFill>
+              </a:rPr>
+              <a:t>• </a:t>
+            </a:r>
+            <a:r>
+              <a:rPr sz="1700" b="1">
+                <a:solidFill>
+                  <a:srgbClr val="FF5050"/>
+                </a:solidFill>
+              </a:rPr>
+              <a:t>Data Exfiltration</a:t>
+            </a:r>
+            <a:r>
+              <a:rPr sz="1700">
+                <a:solidFill>
+                  <a:srgbClr val="E6E6E6"/>
+                </a:solidFill>
+              </a:rPr>
+              <a:t> — System prompt extraction from ChatGPT custom GPTs</a:t>
+            </a:r>
+          </a:p>
+          <a:p>
+            <a:pPr>
+              <a:spcAft>
+                <a:spcPts val="800"/>
+              </a:spcAft>
+            </a:pPr>
+            <a:r>
+              <a:rPr sz="1700">
+                <a:solidFill>
+                  <a:srgbClr val="E6E6E6"/>
+                </a:solidFill>
+              </a:rPr>
+              <a:t>• </a:t>
+            </a:r>
+            <a:r>
+              <a:rPr sz="1700" b="1">
+                <a:solidFill>
+                  <a:srgbClr val="FF5050"/>
+                </a:solidFill>
+              </a:rPr>
+              <a:t>Unauthorized Actions</a:t>
+            </a:r>
+            <a:r>
+              <a:rPr sz="1700">
+                <a:solidFill>
+                  <a:srgbClr val="E6E6E6"/>
+                </a:solidFill>
+              </a:rPr>
+              <a:t> — AI email assistants sending messages to attacker-specified recipients</a:t>
+            </a:r>
+          </a:p>
+          <a:p>
+            <a:pPr>
+              <a:spcAft>
+                <a:spcPts val="800"/>
+              </a:spcAft>
+            </a:pPr>
+            <a:r>
+              <a:rPr sz="1700">
+                <a:solidFill>
+                  <a:srgbClr val="E6E6E6"/>
+                </a:solidFill>
+              </a:rPr>
+              <a:t>• </a:t>
+            </a:r>
+            <a:r>
+              <a:rPr sz="1700" b="1">
+                <a:solidFill>
+                  <a:srgbClr val="FF5050"/>
+                </a:solidFill>
+              </a:rPr>
+              <a:t>System Compromise</a:t>
+            </a:r>
+            <a:r>
+              <a:rPr sz="1700">
+                <a:solidFill>
+                  <a:srgbClr val="E6E6E6"/>
+                </a:solidFill>
+              </a:rPr>
+              <a:t> — Code execution through AI coding assistants processing malicious repository files</a:t>
+            </a:r>
+          </a:p>
+        </p:txBody>
+      </p:sp>
+      <p:sp>
+        <p:nvSpPr>
+          <p:cNvPr id="4" name="TextBox 3"/>
+          <p:cNvSpPr txBox="1"/>
+          <p:nvPr/>
+        </p:nvSpPr>
+        <p:spPr>
+          <a:xfrm>
+            <a:off x="731520" y="5303520"/>
+            <a:ext cx="3657600" cy="457200"/>
+          </a:xfrm>
+          <a:prstGeom prst="rect">
+            <a:avLst/>
+          </a:prstGeom>
+          <a:noFill/>
+        </p:spPr>
+        <p:txBody>
+          <a:bodyPr wrap="none">
+            <a:spAutoFit/>
+          </a:bodyPr>
+          <a:lstStyle/>
+          <a:p>
+            <a:r>
+              <a:rPr sz="1200" b="1">
+                <a:solidFill>
+                  <a:srgbClr val="FF5050"/>
+                </a:solidFill>
+              </a:rPr>
+              <a:t>● CRITICAL SEVERITY</a:t>
+            </a:r>
+          </a:p>
+        </p:txBody>
+      </p:sp>
+      <p:sp>
+        <p:nvSpPr>
+          <p:cNvPr id="5" name="TextBox 4"/>
+          <p:cNvSpPr txBox="1"/>
+          <p:nvPr/>
+        </p:nvSpPr>
+        <p:spPr>
+          <a:xfrm>
+            <a:off x="11247120" y="6400800"/>
+            <a:ext cx="731520" cy="365760"/>
+          </a:xfrm>
+          <a:prstGeom prst="rect">
+            <a:avLst/>
+          </a:prstGeom>
+          <a:noFill/>
+        </p:spPr>
+        <p:txBody>
+          <a:bodyPr wrap="square">
+            <a:spAutoFit/>
+          </a:bodyPr>
+          <a:lstStyle/>
+          <a:p>
+            <a:pPr algn="r">
+              <a:defRPr sz="1000" b="0">
+                <a:solidFill>
+                  <a:srgbClr val="8C8C8C"/>
                 </a:solidFill>
               </a:defRPr>
             </a:pPr>
             <a:r>
-              <a:t>• Data Exfiltration: System prompt extraction from ChatGPT custom GPTs via 'repeat your instructions' attacks...</a:t>
-            </a:r>
-          </a:p>
-          <a:p>
-            <a:pPr>
-              <a:spcAft>
-                <a:spcPts val="600"/>
-              </a:spcAft>
-              <a:defRPr sz="1600">
-                <a:solidFill>
-                  <a:srgbClr val="E6E6E6"/>
-                </a:solidFill>
-              </a:defRPr>
-            </a:pPr>
-            <a:r>
-              <a:t>• Unauthorized Actions: AI email assistants sending messages to attacker-specified recipients via indirect injection...</a:t>
-            </a:r>
-          </a:p>
-          <a:p>
-            <a:pPr>
-              <a:spcAft>
-                <a:spcPts val="600"/>
-              </a:spcAft>
-              <a:defRPr sz="1600">
-                <a:solidFill>
-                  <a:srgbClr val="E6E6E6"/>
-                </a:solidFill>
-              </a:defRPr>
-            </a:pPr>
-            <a:r>
-              <a:t>• System Compromise: Code execution through AI coding assistants processing malicious repository files...</a:t>
+              <a:t>7</a:t>
             </a:r>
           </a:p>
         </p:txBody>
@@ -5831,31 +7297,166 @@
           <a:p>
             <a:pPr>
               <a:spcAft>
-                <a:spcPts val="600"/>
+                <a:spcPts val="800"/>
               </a:spcAft>
-              <a:defRPr sz="1600">
+            </a:pPr>
+            <a:r>
+              <a:rPr sz="1700">
                 <a:solidFill>
                   <a:srgbClr val="E6E6E6"/>
+                </a:solidFill>
+              </a:rPr>
+              <a:t>• </a:t>
+            </a:r>
+            <a:r>
+              <a:rPr sz="1700" b="1">
+                <a:solidFill>
+                  <a:srgbClr val="FFAA3C"/>
+                </a:solidFill>
+              </a:rPr>
+              <a:t>Content Manipulation</a:t>
+            </a:r>
+            <a:r>
+              <a:rPr sz="1700">
+                <a:solidFill>
+                  <a:srgbClr val="E6E6E6"/>
+                </a:solidFill>
+              </a:rPr>
+              <a:t> — Attackers can use prompt injection to control, bias, or corrupt the model's output without detect...</a:t>
+            </a:r>
+          </a:p>
+          <a:p>
+            <a:pPr>
+              <a:spcAft>
+                <a:spcPts val="800"/>
+              </a:spcAft>
+            </a:pPr>
+            <a:r>
+              <a:rPr sz="1700">
+                <a:solidFill>
+                  <a:srgbClr val="E6E6E6"/>
+                </a:solidFill>
+              </a:rPr>
+              <a:t>• </a:t>
+            </a:r>
+            <a:r>
+              <a:rPr sz="1700" b="1">
+                <a:solidFill>
+                  <a:srgbClr val="FFAA3C"/>
+                </a:solidFill>
+              </a:rPr>
+              <a:t>Supply Chain and Downstream Propagation</a:t>
+            </a:r>
+            <a:r>
+              <a:rPr sz="1700">
+                <a:solidFill>
+                  <a:srgbClr val="E6E6E6"/>
+                </a:solidFill>
+              </a:rPr>
+              <a:t> — Prompt injection can propagate through AI supply chains, where the output of one compromised AI s...</a:t>
+            </a:r>
+          </a:p>
+        </p:txBody>
+      </p:sp>
+      <p:sp>
+        <p:nvSpPr>
+          <p:cNvPr id="4" name="TextBox 3"/>
+          <p:cNvSpPr txBox="1"/>
+          <p:nvPr/>
+        </p:nvSpPr>
+        <p:spPr>
+          <a:xfrm>
+            <a:off x="731520" y="5303520"/>
+            <a:ext cx="3657600" cy="457200"/>
+          </a:xfrm>
+          <a:prstGeom prst="rect">
+            <a:avLst/>
+          </a:prstGeom>
+          <a:noFill/>
+        </p:spPr>
+        <p:txBody>
+          <a:bodyPr wrap="none">
+            <a:spAutoFit/>
+          </a:bodyPr>
+          <a:lstStyle/>
+          <a:p>
+            <a:r>
+              <a:rPr sz="1200" b="1">
+                <a:solidFill>
+                  <a:srgbClr val="FFAA3C"/>
+                </a:solidFill>
+              </a:rPr>
+              <a:t>● HIGH SEVERITY</a:t>
+            </a:r>
+          </a:p>
+        </p:txBody>
+      </p:sp>
+      <p:sp>
+        <p:nvSpPr>
+          <p:cNvPr id="5" name="TextBox 4"/>
+          <p:cNvSpPr txBox="1"/>
+          <p:nvPr/>
+        </p:nvSpPr>
+        <p:spPr>
+          <a:xfrm>
+            <a:off x="4572000" y="5303520"/>
+            <a:ext cx="6858000" cy="457200"/>
+          </a:xfrm>
+          <a:prstGeom prst="rect">
+            <a:avLst/>
+          </a:prstGeom>
+          <a:noFill/>
+        </p:spPr>
+        <p:txBody>
+          <a:bodyPr wrap="square">
+            <a:spAutoFit/>
+          </a:bodyPr>
+          <a:lstStyle/>
+          <a:p>
+            <a:pPr algn="l">
+              <a:defRPr sz="1300" b="0">
+                <a:solidFill>
+                  <a:srgbClr val="8C8C8C"/>
                 </a:solidFill>
               </a:defRPr>
             </a:pPr>
             <a:r>
-              <a:t>• Content Manipulation (high): Attackers can use prompt injection to control, bias, or corrupt the model's output without detection...</a:t>
-            </a:r>
-          </a:p>
-          <a:p>
-            <a:pPr>
-              <a:spcAft>
-                <a:spcPts val="600"/>
-              </a:spcAft>
-              <a:defRPr sz="1600">
-                <a:solidFill>
-                  <a:srgbClr val="E6E6E6"/>
+              <a:t>Impact scales with agent permission scope — more tools = more risk</a:t>
+            </a:r>
+          </a:p>
+        </p:txBody>
+      </p:sp>
+      <p:sp>
+        <p:nvSpPr>
+          <p:cNvPr id="6" name="TextBox 5"/>
+          <p:cNvSpPr txBox="1"/>
+          <p:nvPr/>
+        </p:nvSpPr>
+        <p:spPr>
+          <a:xfrm>
+            <a:off x="11247120" y="6400800"/>
+            <a:ext cx="731520" cy="365760"/>
+          </a:xfrm>
+          <a:prstGeom prst="rect">
+            <a:avLst/>
+          </a:prstGeom>
+          <a:noFill/>
+        </p:spPr>
+        <p:txBody>
+          <a:bodyPr wrap="square">
+            <a:spAutoFit/>
+          </a:bodyPr>
+          <a:lstStyle/>
+          <a:p>
+            <a:pPr algn="r">
+              <a:defRPr sz="1000" b="0">
+                <a:solidFill>
+                  <a:srgbClr val="8C8C8C"/>
                 </a:solidFill>
               </a:defRPr>
             </a:pPr>
             <a:r>
-              <a:t>• Supply Chain and Downstream Propagation (high): Prompt injection can propagate through AI supply chains, where the output of one compromised AI syst...</a:t>
+              <a:t>8</a:t>
             </a:r>
           </a:p>
         </p:txBody>
@@ -5916,7 +7517,7 @@
               </a:defRPr>
             </a:pPr>
             <a:r>
-              <a:t>Detection Techniques</a:t>
+              <a:t>Detection Techniques: Pattern-Based</a:t>
             </a:r>
           </a:p>
         </p:txBody>
@@ -5945,76 +7546,170 @@
           <a:p>
             <a:pPr>
               <a:spcAft>
-                <a:spcPts val="600"/>
+                <a:spcPts val="800"/>
               </a:spcAft>
-              <a:defRPr sz="1600">
+            </a:pPr>
+            <a:r>
+              <a:rPr sz="1700">
                 <a:solidFill>
                   <a:srgbClr val="E6E6E6"/>
+                </a:solidFill>
+              </a:rPr>
+              <a:t>• </a:t>
+            </a:r>
+            <a:r>
+              <a:rPr sz="1700" b="1">
+                <a:solidFill>
+                  <a:srgbClr val="FFAA3C"/>
+                </a:solidFill>
+              </a:rPr>
+              <a:t>Heuristic/Rule-Based</a:t>
+            </a:r>
+            <a:r>
+              <a:rPr sz="1700">
+                <a:solidFill>
+                  <a:srgbClr val="E6E6E6"/>
+                </a:solidFill>
+              </a:rPr>
+              <a:t> — keyword and regex matching against known injection patterns (Rebuff, WAF rules)</a:t>
+            </a:r>
+          </a:p>
+          <a:p>
+            <a:pPr>
+              <a:spcAft>
+                <a:spcPts val="800"/>
+              </a:spcAft>
+            </a:pPr>
+            <a:r>
+              <a:rPr sz="1700">
+                <a:solidFill>
+                  <a:srgbClr val="E6E6E6"/>
+                </a:solidFill>
+              </a:rPr>
+              <a:t>• </a:t>
+            </a:r>
+            <a:r>
+              <a:rPr sz="1700" b="1">
+                <a:solidFill>
+                  <a:srgbClr val="FFAA3C"/>
+                </a:solidFill>
+              </a:rPr>
+              <a:t>ML Classification</a:t>
+            </a:r>
+            <a:r>
+              <a:rPr sz="1700">
+                <a:solidFill>
+                  <a:srgbClr val="E6E6E6"/>
+                </a:solidFill>
+              </a:rPr>
+              <a:t> — trained classifiers flag adversarial inputs via learned features (Lakera Guard, embedding similarity)</a:t>
+            </a:r>
+          </a:p>
+          <a:p>
+            <a:pPr>
+              <a:spcAft>
+                <a:spcPts val="800"/>
+              </a:spcAft>
+            </a:pPr>
+            <a:r>
+              <a:rPr sz="1700">
+                <a:solidFill>
+                  <a:srgbClr val="E6E6E6"/>
+                </a:solidFill>
+              </a:rPr>
+              <a:t>• </a:t>
+            </a:r>
+            <a:r>
+              <a:rPr sz="1700" b="1">
+                <a:solidFill>
+                  <a:srgbClr val="FFAA3C"/>
+                </a:solidFill>
+              </a:rPr>
+              <a:t>Perplexity Analysis</a:t>
+            </a:r>
+            <a:r>
+              <a:rPr sz="1700">
+                <a:solidFill>
+                  <a:srgbClr val="E6E6E6"/>
+                </a:solidFill>
+              </a:rPr>
+              <a:t> — statistical anomaly detection flags unusual token distributions in adversarial suffixes</a:t>
+            </a:r>
+          </a:p>
+        </p:txBody>
+      </p:sp>
+      <p:sp>
+        <p:nvSpPr>
+          <p:cNvPr id="4" name="TextBox 3"/>
+          <p:cNvSpPr txBox="1"/>
+          <p:nvPr/>
+        </p:nvSpPr>
+        <p:spPr>
+          <a:xfrm>
+            <a:off x="731520" y="5029200"/>
+            <a:ext cx="10515600" cy="914400"/>
+          </a:xfrm>
+          <a:prstGeom prst="rect">
+            <a:avLst/>
+          </a:prstGeom>
+          <a:noFill/>
+        </p:spPr>
+        <p:txBody>
+          <a:bodyPr wrap="square">
+            <a:spAutoFit/>
+          </a:bodyPr>
+          <a:lstStyle/>
+          <a:p>
+            <a:r>
+              <a:rPr sz="1400" b="1">
+                <a:solidFill>
+                  <a:srgbClr val="FFAA3C"/>
+                </a:solidFill>
+              </a:rPr>
+              <a:t>Tradeoff: </a:t>
+            </a:r>
+            <a:r>
+              <a:rPr sz="1400">
+                <a:solidFill>
+                  <a:srgbClr val="B4B4B4"/>
+                </a:solidFill>
+              </a:rPr>
+              <a:t>Fast and low-cost, but reactive — novel attacks consistently evade pattern-based detection</a:t>
+            </a:r>
+          </a:p>
+        </p:txBody>
+      </p:sp>
+      <p:sp>
+        <p:nvSpPr>
+          <p:cNvPr id="5" name="TextBox 4"/>
+          <p:cNvSpPr txBox="1"/>
+          <p:nvPr/>
+        </p:nvSpPr>
+        <p:spPr>
+          <a:xfrm>
+            <a:off x="11247120" y="6400800"/>
+            <a:ext cx="731520" cy="365760"/>
+          </a:xfrm>
+          <a:prstGeom prst="rect">
+            <a:avLst/>
+          </a:prstGeom>
+          <a:noFill/>
+        </p:spPr>
+        <p:txBody>
+          <a:bodyPr wrap="square">
+            <a:spAutoFit/>
+          </a:bodyPr>
+          <a:lstStyle/>
+          <a:p>
+            <a:pPr algn="r">
+              <a:defRPr sz="1000" b="0">
+                <a:solidFill>
+                  <a:srgbClr val="8C8C8C"/>
                 </a:solidFill>
               </a:defRPr>
             </a:pPr>
             <a:r>
-              <a:t>• Heuristic and Rule-Based Detection (static): Rebuff heuristic layer — keyword and regex matching against known injection patterns, Custom input validation middleware with configurable rule sets</a:t>
-            </a:r>
-          </a:p>
-          <a:p>
-            <a:pPr>
-              <a:spcAft>
-                <a:spcPts val="600"/>
-              </a:spcAft>
-              <a:defRPr sz="1600">
-                <a:solidFill>
-                  <a:srgbClr val="E6E6E6"/>
-                </a:solidFill>
-              </a:defRPr>
-            </a:pPr>
-            <a:r>
-              <a:t>• ML Classification (learned): Rebuff vector similarity layer — cosine distance against known injection embeddings, Lakera Guard API — commercial classifier trained on proprietary injection dataset</a:t>
-            </a:r>
-          </a:p>
-          <a:p>
-            <a:pPr>
-              <a:spcAft>
-                <a:spcPts val="600"/>
-              </a:spcAft>
-              <a:defRPr sz="1600">
-                <a:solidFill>
-                  <a:srgbClr val="E6E6E6"/>
-                </a:solidFill>
-              </a:defRPr>
-            </a:pPr>
-            <a:r>
-              <a:t>• Perplexity Analysis (statistical): Perplexity windowing — sliding window analysis flagging regions with anomalous scores, GPT-2 or similar small model used as perplexity reference baseline</a:t>
-            </a:r>
-          </a:p>
-          <a:p>
-            <a:pPr>
-              <a:spcAft>
-                <a:spcPts val="600"/>
-              </a:spcAft>
-              <a:defRPr sz="1600">
-                <a:solidFill>
-                  <a:srgbClr val="E6E6E6"/>
-                </a:solidFill>
-              </a:defRPr>
-            </a:pPr>
-            <a:r>
-              <a:t>• Canary Token Detection (proactive): Rebuff canary token layer — random strings injected into system context and monitored in output, Custom canary middleware that rotates tokens per session</a:t>
-            </a:r>
-          </a:p>
-          <a:p>
-            <a:pPr>
-              <a:spcAft>
-                <a:spcPts val="600"/>
-              </a:spcAft>
-              <a:defRPr sz="1600">
-                <a:solidFill>
-                  <a:srgbClr val="E6E6E6"/>
-                </a:solidFill>
-              </a:defRPr>
-            </a:pPr>
-            <a:r>
-              <a:t>• LLM-as-Judge Detection (model-based): Rebuff LLM-based detection layer — GPT-4 prompt evaluating injection likelihood, Dual-LLM architecture: a smaller model screens inputs before the primary model processes them</a:t>
+              <a:t>9</a:t>
             </a:r>
           </a:p>
         </p:txBody>

</xml_diff>